<commit_message>
Add ~250 athletes per department slide to PIL investor deck
Inserts a new slide between Contract Economics and the Beachhead slide
outlining the deployment unit: ~250 athletes per athletic department,
full-roster coverage, and the per-department contract value math.

Co-Authored-By: Claude Fable 5 <noreply@anthropic.com>
Claude-Session: https://claude.ai/code/session_01Ddg1x2r2jmnR7KFcVUxRND
</commit_message>
<xml_diff>
--- a/public/PIL_Investor_Deck_2026.pptx
+++ b/public/PIL_Investor_Deck_2026.pptx
@@ -20,6 +20,7 @@
     <p:sldId id="265" r:id="rId17"/>
     <p:sldId id="266" r:id="rId18"/>
     <p:sldId id="267" r:id="rId19"/>
+    <p:sldId id="275" r:id="rId27"/>
     <p:sldId id="268" r:id="rId20"/>
     <p:sldId id="269" r:id="rId21"/>
     <p:sldId id="270" r:id="rId22"/>
@@ -16506,6 +16507,830 @@
     <a:masterClrMapping/>
   </p:clrMapOvr>
   <p:transition xmlns:p14="http://schemas.microsoft.com/office/powerpoint/2010/main" spd="med" advClick="1"/>
+</p:sld>
+</file>
+
+<file path=ppt/slides/slide20.xml><?xml version="1.0" encoding="utf-8"?>
+<p:sld xmlns:a="http://schemas.openxmlformats.org/drawingml/2006/main" xmlns:r="http://schemas.openxmlformats.org/officeDocument/2006/relationships" xmlns:p="http://schemas.openxmlformats.org/presentationml/2006/main">
+  <p:cSld name="Slide 1">
+    <p:bg>
+      <p:bgPr>
+        <a:solidFill>
+          <a:srgbClr val="0A0B0D"/>
+        </a:solidFill>
+      </p:bgPr>
+    </p:bg>
+    <p:spTree>
+      <p:nvGrpSpPr>
+        <p:cNvPr id="1" name=""/>
+        <p:cNvGrpSpPr/>
+        <p:nvPr/>
+      </p:nvGrpSpPr>
+      <p:grpSpPr>
+        <a:xfrm>
+          <a:off x="0" y="0"/>
+          <a:ext cx="0" cy="0"/>
+          <a:chOff x="0" y="0"/>
+          <a:chExt cx="0" cy="0"/>
+        </a:xfrm>
+      </p:grpSpPr>
+      <p:sp>
+        <p:nvSpPr>
+          <p:cNvPr id="2" name="Shape 0"/>
+          <p:cNvSpPr/>
+          <p:nvPr/>
+        </p:nvSpPr>
+        <p:spPr>
+          <a:xfrm>
+            <a:off x="822960" y="548640"/>
+            <a:ext cx="2673706" cy="384048"/>
+          </a:xfrm>
+          <a:prstGeom prst="roundRect">
+            <a:avLst>
+              <a:gd name="adj" fmla="val 50000"/>
+            </a:avLst>
+          </a:prstGeom>
+          <a:solidFill>
+            <a:srgbClr val="121317"/>
+          </a:solidFill>
+          <a:ln w="12700">
+            <a:solidFill>
+              <a:srgbClr val="2A2C33"/>
+            </a:solidFill>
+            <a:prstDash val="solid"/>
+          </a:ln>
+        </p:spPr>
+      </p:sp>
+      <p:sp>
+        <p:nvSpPr>
+          <p:cNvPr id="3" name="Text 1"/>
+          <p:cNvSpPr/>
+          <p:nvPr/>
+        </p:nvSpPr>
+        <p:spPr>
+          <a:xfrm>
+            <a:off x="822960" y="548640"/>
+            <a:ext cx="2673706" cy="384048"/>
+          </a:xfrm>
+          <a:prstGeom prst="rect">
+            <a:avLst/>
+          </a:prstGeom>
+          <a:noFill/>
+          <a:ln/>
+        </p:spPr>
+        <p:txBody>
+          <a:bodyPr wrap="square" lIns="0" tIns="0" rIns="0" bIns="0" rtlCol="0" anchor="ctr"/>
+          <a:lstStyle/>
+          <a:p>
+            <a:pPr algn="ctr" indent="0" marL="0">
+              <a:buNone/>
+            </a:pPr>
+            <a:r>
+              <a:rPr lang="en-US" sz="700" dirty="0">
+                <a:solidFill>
+                  <a:srgbClr val="C8FF00"/>
+                </a:solidFill>
+                <a:latin typeface="Arial" pitchFamily="34" charset="0"/>
+                <a:ea typeface="Arial" pitchFamily="34" charset="-122"/>
+                <a:cs typeface="Arial" pitchFamily="34" charset="-120"/>
+              </a:rPr>
+              <a:t>● </a:t>
+            </a:r>
+            <a:pPr algn="ctr" indent="0" marL="0">
+              <a:buNone/>
+            </a:pPr>
+            <a:r>
+              <a:rPr lang="en-US" sz="1000" b="1" spc="300" kern="0" dirty="0">
+                <a:solidFill>
+                  <a:srgbClr val="F2F2F0"/>
+                </a:solidFill>
+                <a:latin typeface="Arial" pitchFamily="34" charset="0"/>
+                <a:ea typeface="Arial" pitchFamily="34" charset="-122"/>
+                <a:cs typeface="Arial" pitchFamily="34" charset="-120"/>
+              </a:rPr>
+              <a:t>CONTRACT ECONOMICS</a:t>
+            </a:r>
+            <a:endParaRPr lang="en-US" sz="700" dirty="0"/>
+          </a:p>
+        </p:txBody>
+      </p:sp>
+      <p:sp>
+        <p:nvSpPr>
+          <p:cNvPr id="4" name="Text 2"/>
+          <p:cNvSpPr/>
+          <p:nvPr/>
+        </p:nvSpPr>
+        <p:spPr>
+          <a:xfrm>
+            <a:off x="777240" y="1463040"/>
+            <a:ext cx="10881360" cy="777240"/>
+          </a:xfrm>
+          <a:prstGeom prst="rect">
+            <a:avLst/>
+          </a:prstGeom>
+          <a:noFill/>
+          <a:ln/>
+        </p:spPr>
+        <p:txBody>
+          <a:bodyPr wrap="square" lIns="0" tIns="0" rIns="0" bIns="0" rtlCol="0" anchor="t"/>
+          <a:lstStyle/>
+          <a:p>
+            <a:pPr algn="l" indent="0" marL="0">
+              <a:buNone/>
+            </a:pPr>
+            <a:r>
+              <a:rPr lang="en-US" sz="3800" b="1" dirty="0">
+                <a:solidFill>
+                  <a:srgbClr val="F2F2F0"/>
+                </a:solidFill>
+                <a:latin typeface="Arial" pitchFamily="34" charset="0"/>
+                <a:ea typeface="Arial" pitchFamily="34" charset="-122"/>
+                <a:cs typeface="Arial" pitchFamily="34" charset="-120"/>
+              </a:rPr>
+              <a:t>One department </a:t>
+            </a:r>
+            <a:pPr algn="l" indent="0" marL="0">
+              <a:buNone/>
+            </a:pPr>
+            <a:r>
+              <a:rPr lang="en-US" sz="3800" b="1" dirty="0">
+                <a:solidFill>
+                  <a:srgbClr val="C8FF00"/>
+                </a:solidFill>
+                <a:latin typeface="Arial" pitchFamily="34" charset="0"/>
+                <a:ea typeface="Arial" pitchFamily="34" charset="-122"/>
+                <a:cs typeface="Arial" pitchFamily="34" charset="-120"/>
+              </a:rPr>
+              <a:t>≈ 250 athletes.</a:t>
+            </a:r>
+            <a:endParaRPr lang="en-US" sz="3800" dirty="0"/>
+          </a:p>
+        </p:txBody>
+      </p:sp>
+      <p:sp>
+        <p:nvSpPr>
+          <p:cNvPr id="5" name="Text 3"/>
+          <p:cNvSpPr/>
+          <p:nvPr/>
+        </p:nvSpPr>
+        <p:spPr>
+          <a:xfrm>
+            <a:off x="804672" y="2212848"/>
+            <a:ext cx="10607040" cy="594360"/>
+          </a:xfrm>
+          <a:prstGeom prst="rect">
+            <a:avLst/>
+          </a:prstGeom>
+          <a:noFill/>
+          <a:ln/>
+        </p:spPr>
+        <p:txBody>
+          <a:bodyPr wrap="square" lIns="0" tIns="0" rIns="0" bIns="0" rtlCol="0" anchor="t"/>
+          <a:lstStyle/>
+          <a:p>
+            <a:pPr algn="l" indent="0" marL="0">
+              <a:buNone/>
+            </a:pPr>
+            <a:r>
+              <a:rPr lang="en-US" sz="1450" dirty="0">
+                <a:solidFill>
+                  <a:srgbClr val="9CA0A8"/>
+                </a:solidFill>
+                <a:latin typeface="Arial" pitchFamily="34" charset="0"/>
+                <a:ea typeface="Arial" pitchFamily="34" charset="-122"/>
+                <a:cs typeface="Arial" pitchFamily="34" charset="-120"/>
+              </a:rPr>
+              <a:t>The average athletic department fields roughly 250 student-athletes — and one contract covers the full roster.</a:t>
+            </a:r>
+            <a:endParaRPr lang="en-US" sz="1450" dirty="0"/>
+          </a:p>
+        </p:txBody>
+      </p:sp>
+      <p:sp>
+        <p:nvSpPr>
+          <p:cNvPr id="6" name="Shape 4"/>
+          <p:cNvSpPr/>
+          <p:nvPr/>
+        </p:nvSpPr>
+        <p:spPr>
+          <a:xfrm>
+            <a:off x="822960" y="2761488"/>
+            <a:ext cx="4206240" cy="3017520"/>
+          </a:xfrm>
+          <a:prstGeom prst="roundRect">
+            <a:avLst>
+              <a:gd name="adj" fmla="val 3939"/>
+            </a:avLst>
+          </a:prstGeom>
+          <a:solidFill>
+            <a:srgbClr val="111309"/>
+          </a:solidFill>
+          <a:ln w="15875">
+            <a:solidFill>
+              <a:srgbClr val="C8FF00"/>
+            </a:solidFill>
+            <a:prstDash val="solid"/>
+          </a:ln>
+        </p:spPr>
+      </p:sp>
+      <p:sp>
+        <p:nvSpPr>
+          <p:cNvPr id="7" name="Text 5"/>
+          <p:cNvSpPr/>
+          <p:nvPr/>
+        </p:nvSpPr>
+        <p:spPr>
+          <a:xfrm>
+            <a:off x="1143000" y="3063240"/>
+            <a:ext cx="3566160" cy="256032"/>
+          </a:xfrm>
+          <a:prstGeom prst="rect">
+            <a:avLst/>
+          </a:prstGeom>
+          <a:noFill/>
+          <a:ln/>
+        </p:spPr>
+        <p:txBody>
+          <a:bodyPr wrap="square" lIns="0" tIns="0" rIns="0" bIns="0" rtlCol="0" anchor="ctr"/>
+          <a:lstStyle/>
+          <a:p>
+            <a:pPr indent="0" marL="0">
+              <a:buNone/>
+            </a:pPr>
+            <a:r>
+              <a:rPr lang="en-US" sz="1150" b="1" spc="200" kern="0" dirty="0">
+                <a:solidFill>
+                  <a:srgbClr val="C8FF00"/>
+                </a:solidFill>
+                <a:latin typeface="Arial" pitchFamily="34" charset="0"/>
+                <a:ea typeface="Arial" pitchFamily="34" charset="-122"/>
+                <a:cs typeface="Arial" pitchFamily="34" charset="-120"/>
+              </a:rPr>
+              <a:t>DEPLOYMENT UNIT</a:t>
+            </a:r>
+            <a:endParaRPr lang="en-US" sz="1150" dirty="0"/>
+          </a:p>
+        </p:txBody>
+      </p:sp>
+      <p:sp>
+        <p:nvSpPr>
+          <p:cNvPr id="8" name="Text 6"/>
+          <p:cNvSpPr/>
+          <p:nvPr/>
+        </p:nvSpPr>
+        <p:spPr>
+          <a:xfrm>
+            <a:off x="1143000" y="3401568"/>
+            <a:ext cx="3566160" cy="914400"/>
+          </a:xfrm>
+          <a:prstGeom prst="rect">
+            <a:avLst/>
+          </a:prstGeom>
+          <a:noFill/>
+          <a:ln/>
+        </p:spPr>
+        <p:txBody>
+          <a:bodyPr wrap="square" lIns="0" tIns="0" rIns="0" bIns="0" rtlCol="0" anchor="ctr"/>
+          <a:lstStyle/>
+          <a:p>
+            <a:pPr indent="0" marL="0">
+              <a:buNone/>
+            </a:pPr>
+            <a:r>
+              <a:rPr lang="en-US" sz="5200" b="1" dirty="0">
+                <a:solidFill>
+                  <a:srgbClr val="F2F2F0"/>
+                </a:solidFill>
+                <a:latin typeface="Arial" pitchFamily="34" charset="0"/>
+                <a:ea typeface="Arial" pitchFamily="34" charset="-122"/>
+                <a:cs typeface="Arial" pitchFamily="34" charset="-120"/>
+              </a:rPr>
+              <a:t>~250</a:t>
+            </a:r>
+            <a:endParaRPr lang="en-US" sz="5200" dirty="0"/>
+          </a:p>
+        </p:txBody>
+      </p:sp>
+      <p:sp>
+        <p:nvSpPr>
+          <p:cNvPr id="9" name="Text 7"/>
+          <p:cNvSpPr/>
+          <p:nvPr/>
+        </p:nvSpPr>
+        <p:spPr>
+          <a:xfrm>
+            <a:off x="1143000" y="4480560"/>
+            <a:ext cx="3566160" cy="320040"/>
+          </a:xfrm>
+          <a:prstGeom prst="rect">
+            <a:avLst/>
+          </a:prstGeom>
+          <a:noFill/>
+          <a:ln/>
+        </p:spPr>
+        <p:txBody>
+          <a:bodyPr wrap="square" lIns="0" tIns="0" rIns="0" bIns="0" rtlCol="0" anchor="ctr"/>
+          <a:lstStyle/>
+          <a:p>
+            <a:pPr indent="0" marL="0">
+              <a:buNone/>
+            </a:pPr>
+            <a:r>
+              <a:rPr lang="en-US" sz="1450" b="1" dirty="0">
+                <a:solidFill>
+                  <a:srgbClr val="F2F2F0"/>
+                </a:solidFill>
+                <a:latin typeface="Arial" pitchFamily="34" charset="0"/>
+                <a:ea typeface="Arial" pitchFamily="34" charset="-122"/>
+                <a:cs typeface="Arial" pitchFamily="34" charset="-120"/>
+              </a:rPr>
+              <a:t>athletes per athletic department</a:t>
+            </a:r>
+            <a:endParaRPr lang="en-US" sz="1450" dirty="0"/>
+          </a:p>
+        </p:txBody>
+      </p:sp>
+      <p:sp>
+        <p:nvSpPr>
+          <p:cNvPr id="10" name="Text 8"/>
+          <p:cNvSpPr/>
+          <p:nvPr/>
+        </p:nvSpPr>
+        <p:spPr>
+          <a:xfrm>
+            <a:off x="1143000" y="4864608"/>
+            <a:ext cx="3566160" cy="274320"/>
+          </a:xfrm>
+          <a:prstGeom prst="rect">
+            <a:avLst/>
+          </a:prstGeom>
+          <a:noFill/>
+          <a:ln/>
+        </p:spPr>
+        <p:txBody>
+          <a:bodyPr wrap="square" lIns="0" tIns="0" rIns="0" bIns="0" rtlCol="0" anchor="ctr"/>
+          <a:lstStyle/>
+          <a:p>
+            <a:pPr indent="0" marL="0">
+              <a:buNone/>
+            </a:pPr>
+            <a:r>
+              <a:rPr lang="en-US" sz="1150" dirty="0">
+                <a:solidFill>
+                  <a:srgbClr val="9CA0A8"/>
+                </a:solidFill>
+                <a:latin typeface="Arial" pitchFamily="34" charset="0"/>
+                <a:ea typeface="Arial" pitchFamily="34" charset="-122"/>
+                <a:cs typeface="Arial" pitchFamily="34" charset="-120"/>
+              </a:rPr>
+              <a:t>across every varsity roster on campus</a:t>
+            </a:r>
+            <a:endParaRPr lang="en-US" sz="1150" dirty="0"/>
+          </a:p>
+        </p:txBody>
+      </p:sp>
+      <p:sp>
+        <p:nvSpPr>
+          <p:cNvPr id="11" name="Text 9"/>
+          <p:cNvSpPr/>
+          <p:nvPr/>
+        </p:nvSpPr>
+        <p:spPr>
+          <a:xfrm>
+            <a:off x="5486400" y="2834640"/>
+            <a:ext cx="5029200" cy="256032"/>
+          </a:xfrm>
+          <a:prstGeom prst="rect">
+            <a:avLst/>
+          </a:prstGeom>
+          <a:noFill/>
+          <a:ln/>
+        </p:spPr>
+        <p:txBody>
+          <a:bodyPr wrap="square" lIns="0" tIns="0" rIns="0" bIns="0" rtlCol="0" anchor="ctr"/>
+          <a:lstStyle/>
+          <a:p>
+            <a:pPr indent="0" marL="0">
+              <a:buNone/>
+            </a:pPr>
+            <a:r>
+              <a:rPr lang="en-US" sz="1150" b="1" spc="200" kern="0" dirty="0">
+                <a:solidFill>
+                  <a:srgbClr val="C8FF00"/>
+                </a:solidFill>
+                <a:latin typeface="Arial" pitchFamily="34" charset="0"/>
+                <a:ea typeface="Arial" pitchFamily="34" charset="-122"/>
+                <a:cs typeface="Arial" pitchFamily="34" charset="-120"/>
+              </a:rPr>
+              <a:t>WHAT ONE DEPARTMENT MEANS</a:t>
+            </a:r>
+            <a:endParaRPr lang="en-US" sz="1150" dirty="0"/>
+          </a:p>
+        </p:txBody>
+      </p:sp>
+      <p:sp>
+        <p:nvSpPr>
+          <p:cNvPr id="12" name="Shape 10"/>
+          <p:cNvSpPr/>
+          <p:nvPr/>
+        </p:nvSpPr>
+        <p:spPr>
+          <a:xfrm>
+            <a:off x="5486400" y="3200400"/>
+            <a:ext cx="5897880" cy="1207008"/>
+          </a:xfrm>
+          <a:prstGeom prst="roundRect">
+            <a:avLst>
+              <a:gd name="adj" fmla="val 9848"/>
+            </a:avLst>
+          </a:prstGeom>
+          <a:solidFill>
+            <a:srgbClr val="141619"/>
+          </a:solidFill>
+          <a:ln w="12700">
+            <a:solidFill>
+              <a:srgbClr val="26282E"/>
+            </a:solidFill>
+            <a:prstDash val="solid"/>
+          </a:ln>
+        </p:spPr>
+      </p:sp>
+      <p:sp>
+        <p:nvSpPr>
+          <p:cNvPr id="13" name="Shape 11"/>
+          <p:cNvSpPr/>
+          <p:nvPr/>
+        </p:nvSpPr>
+        <p:spPr>
+          <a:xfrm>
+            <a:off x="5779008" y="3502152"/>
+            <a:ext cx="603504" cy="603504"/>
+          </a:xfrm>
+          <a:prstGeom prst="ellipse">
+            <a:avLst/>
+          </a:prstGeom>
+          <a:solidFill>
+            <a:srgbClr val="1C1E14"/>
+          </a:solidFill>
+          <a:ln/>
+        </p:spPr>
+      </p:sp>
+      <p:pic>
+        <p:nvPicPr>
+          <p:cNvPr id="14" name="Image 0" descr="/tmp/claude-0/-home-user-QuickLifts-Web/26b019cd-7888-5ab3-ba1c-caeae67de894/scratchpad/assets/p08-i059.png">    </p:cNvPr>
+          <p:cNvPicPr>
+            <a:picLocks noChangeAspect="1"/>
+          </p:cNvPicPr>
+          <p:nvPr/>
+        </p:nvPicPr>
+        <p:blipFill>
+          <a:blip r:embed="rId1"/>
+          <a:stretch>
+            <a:fillRect/>
+          </a:stretch>
+        </p:blipFill>
+        <p:spPr>
+          <a:xfrm>
+            <a:off x="5934456" y="3657600"/>
+            <a:ext cx="292608" cy="292608"/>
+          </a:xfrm>
+          <a:prstGeom prst="rect">
+            <a:avLst/>
+          </a:prstGeom>
+        </p:spPr>
+      </p:pic>
+      <p:sp>
+        <p:nvSpPr>
+          <p:cNvPr id="15" name="Text 12"/>
+          <p:cNvSpPr/>
+          <p:nvPr/>
+        </p:nvSpPr>
+        <p:spPr>
+          <a:xfrm>
+            <a:off x="6629400" y="3401568"/>
+            <a:ext cx="4572000" cy="320040"/>
+          </a:xfrm>
+          <a:prstGeom prst="rect">
+            <a:avLst/>
+          </a:prstGeom>
+          <a:noFill/>
+          <a:ln/>
+        </p:spPr>
+        <p:txBody>
+          <a:bodyPr wrap="square" lIns="0" tIns="0" rIns="0" bIns="0" rtlCol="0" anchor="ctr"/>
+          <a:lstStyle/>
+          <a:p>
+            <a:pPr indent="0" marL="0">
+              <a:buNone/>
+            </a:pPr>
+            <a:r>
+              <a:rPr lang="en-US" sz="1600" b="1" dirty="0">
+                <a:solidFill>
+                  <a:srgbClr val="F2F2F0"/>
+                </a:solidFill>
+                <a:latin typeface="Arial" pitchFamily="34" charset="0"/>
+                <a:ea typeface="Arial" pitchFamily="34" charset="-122"/>
+                <a:cs typeface="Arial" pitchFamily="34" charset="-120"/>
+              </a:rPr>
+              <a:t>One contract, every team</a:t>
+            </a:r>
+            <a:endParaRPr lang="en-US" sz="1600" dirty="0"/>
+          </a:p>
+        </p:txBody>
+      </p:sp>
+      <p:sp>
+        <p:nvSpPr>
+          <p:cNvPr id="16" name="Text 13"/>
+          <p:cNvSpPr/>
+          <p:nvPr/>
+        </p:nvSpPr>
+        <p:spPr>
+          <a:xfrm>
+            <a:off x="6629400" y="3749040"/>
+            <a:ext cx="4572000" cy="548640"/>
+          </a:xfrm>
+          <a:prstGeom prst="rect">
+            <a:avLst/>
+          </a:prstGeom>
+          <a:noFill/>
+          <a:ln/>
+        </p:spPr>
+        <p:txBody>
+          <a:bodyPr wrap="square" lIns="0" tIns="0" rIns="0" bIns="0" rtlCol="0" anchor="ctr"/>
+          <a:lstStyle/>
+          <a:p>
+            <a:pPr indent="0" marL="0">
+              <a:lnSpc>
+                <a:spcPts val="1600"/>
+              </a:lnSpc>
+              <a:buNone/>
+            </a:pPr>
+            <a:r>
+              <a:rPr lang="en-US" sz="1200" dirty="0">
+                <a:solidFill>
+                  <a:srgbClr val="9CA0A8"/>
+                </a:solidFill>
+                <a:latin typeface="Arial" pitchFamily="34" charset="0"/>
+                <a:ea typeface="Arial" pitchFamily="34" charset="-122"/>
+                <a:cs typeface="Arial" pitchFamily="34" charset="-120"/>
+              </a:rPr>
+              <a:t>Coverage spans the whole department — football to track — not per-sport seats or team-by-team sales.</a:t>
+            </a:r>
+            <a:endParaRPr lang="en-US" sz="1200" dirty="0"/>
+          </a:p>
+        </p:txBody>
+      </p:sp>
+      <p:sp>
+        <p:nvSpPr>
+          <p:cNvPr id="17" name="Shape 14"/>
+          <p:cNvSpPr/>
+          <p:nvPr/>
+        </p:nvSpPr>
+        <p:spPr>
+          <a:xfrm>
+            <a:off x="5486400" y="4553712"/>
+            <a:ext cx="5897880" cy="1207008"/>
+          </a:xfrm>
+          <a:prstGeom prst="roundRect">
+            <a:avLst>
+              <a:gd name="adj" fmla="val 9848"/>
+            </a:avLst>
+          </a:prstGeom>
+          <a:solidFill>
+            <a:srgbClr val="141619"/>
+          </a:solidFill>
+          <a:ln w="12700">
+            <a:solidFill>
+              <a:srgbClr val="26282E"/>
+            </a:solidFill>
+            <a:prstDash val="solid"/>
+          </a:ln>
+        </p:spPr>
+      </p:sp>
+      <p:sp>
+        <p:nvSpPr>
+          <p:cNvPr id="18" name="Shape 15"/>
+          <p:cNvSpPr/>
+          <p:nvPr/>
+        </p:nvSpPr>
+        <p:spPr>
+          <a:xfrm>
+            <a:off x="5779008" y="4855464"/>
+            <a:ext cx="603504" cy="603504"/>
+          </a:xfrm>
+          <a:prstGeom prst="ellipse">
+            <a:avLst/>
+          </a:prstGeom>
+          <a:solidFill>
+            <a:srgbClr val="1C1E14"/>
+          </a:solidFill>
+          <a:ln/>
+        </p:spPr>
+      </p:sp>
+      <p:pic>
+        <p:nvPicPr>
+          <p:cNvPr id="19" name="Image 1" descr="/tmp/claude-0/-home-user-QuickLifts-Web/26b019cd-7888-5ab3-ba1c-caeae67de894/scratchpad/assets/p08-i071.png">    </p:cNvPr>
+          <p:cNvPicPr>
+            <a:picLocks noChangeAspect="1"/>
+          </p:cNvPicPr>
+          <p:nvPr/>
+        </p:nvPicPr>
+        <p:blipFill>
+          <a:blip r:embed="rId2"/>
+          <a:stretch>
+            <a:fillRect/>
+          </a:stretch>
+        </p:blipFill>
+        <p:spPr>
+          <a:xfrm>
+            <a:off x="5934456" y="5010912"/>
+            <a:ext cx="292608" cy="292608"/>
+          </a:xfrm>
+          <a:prstGeom prst="rect">
+            <a:avLst/>
+          </a:prstGeom>
+        </p:spPr>
+      </p:pic>
+      <p:sp>
+        <p:nvSpPr>
+          <p:cNvPr id="20" name="Text 16"/>
+          <p:cNvSpPr/>
+          <p:nvPr/>
+        </p:nvSpPr>
+        <p:spPr>
+          <a:xfrm>
+            <a:off x="6629400" y="4754880"/>
+            <a:ext cx="4572000" cy="320040"/>
+          </a:xfrm>
+          <a:prstGeom prst="rect">
+            <a:avLst/>
+          </a:prstGeom>
+          <a:noFill/>
+          <a:ln/>
+        </p:spPr>
+        <p:txBody>
+          <a:bodyPr wrap="square" lIns="0" tIns="0" rIns="0" bIns="0" rtlCol="0" anchor="ctr"/>
+          <a:lstStyle/>
+          <a:p>
+            <a:pPr indent="0" marL="0">
+              <a:buNone/>
+            </a:pPr>
+            <a:r>
+              <a:rPr lang="en-US" sz="1600" b="1" dirty="0">
+                <a:solidFill>
+                  <a:srgbClr val="F2F2F0"/>
+                </a:solidFill>
+                <a:latin typeface="Arial" pitchFamily="34" charset="0"/>
+                <a:ea typeface="Arial" pitchFamily="34" charset="-122"/>
+                <a:cs typeface="Arial" pitchFamily="34" charset="-120"/>
+              </a:rPr>
+              <a:t>Value scales with the roster</a:t>
+            </a:r>
+            <a:endParaRPr lang="en-US" sz="1600" dirty="0"/>
+          </a:p>
+        </p:txBody>
+      </p:sp>
+      <p:sp>
+        <p:nvSpPr>
+          <p:cNvPr id="21" name="Text 17"/>
+          <p:cNvSpPr/>
+          <p:nvPr/>
+        </p:nvSpPr>
+        <p:spPr>
+          <a:xfrm>
+            <a:off x="6629400" y="5102352"/>
+            <a:ext cx="4572000" cy="548640"/>
+          </a:xfrm>
+          <a:prstGeom prst="rect">
+            <a:avLst/>
+          </a:prstGeom>
+          <a:noFill/>
+          <a:ln/>
+        </p:spPr>
+        <p:txBody>
+          <a:bodyPr wrap="square" lIns="0" tIns="0" rIns="0" bIns="0" rtlCol="0" anchor="ctr"/>
+          <a:lstStyle/>
+          <a:p>
+            <a:pPr indent="0" marL="0">
+              <a:lnSpc>
+                <a:spcPts val="1600"/>
+              </a:lnSpc>
+              <a:buNone/>
+            </a:pPr>
+            <a:r>
+              <a:rPr lang="en-US" sz="1200" dirty="0">
+                <a:solidFill>
+                  <a:srgbClr val="9CA0A8"/>
+                </a:solidFill>
+                <a:latin typeface="Arial" pitchFamily="34" charset="0"/>
+                <a:ea typeface="Arial" pitchFamily="34" charset="-122"/>
+                <a:cs typeface="Arial" pitchFamily="34" charset="-120"/>
+              </a:rPr>
+              <a:t>~250 athletes × $300 per athlete ≈ $75K per department, per year at full price.</a:t>
+            </a:r>
+            <a:endParaRPr lang="en-US" sz="1200" dirty="0"/>
+          </a:p>
+        </p:txBody>
+      </p:sp>
+      <p:sp>
+        <p:nvSpPr>
+          <p:cNvPr id="22" name="Shape 18"/>
+          <p:cNvSpPr/>
+          <p:nvPr/>
+        </p:nvSpPr>
+        <p:spPr>
+          <a:xfrm>
+            <a:off x="822960" y="6053328"/>
+            <a:ext cx="10561320" cy="530352"/>
+          </a:xfrm>
+          <a:prstGeom prst="roundRect">
+            <a:avLst>
+              <a:gd name="adj" fmla="val 22414"/>
+            </a:avLst>
+          </a:prstGeom>
+          <a:solidFill>
+            <a:srgbClr val="111309"/>
+          </a:solidFill>
+          <a:ln w="15875">
+            <a:solidFill>
+              <a:srgbClr val="C8FF00"/>
+            </a:solidFill>
+            <a:prstDash val="solid"/>
+          </a:ln>
+        </p:spPr>
+      </p:sp>
+      <p:sp>
+        <p:nvSpPr>
+          <p:cNvPr id="23" name="Text 19"/>
+          <p:cNvSpPr/>
+          <p:nvPr/>
+        </p:nvSpPr>
+        <p:spPr>
+          <a:xfrm>
+            <a:off x="1051560" y="6053328"/>
+            <a:ext cx="10104120" cy="530352"/>
+          </a:xfrm>
+          <a:prstGeom prst="rect">
+            <a:avLst/>
+          </a:prstGeom>
+          <a:noFill/>
+          <a:ln/>
+        </p:spPr>
+        <p:txBody>
+          <a:bodyPr wrap="square" lIns="0" tIns="0" rIns="0" bIns="0" rtlCol="0" anchor="ctr"/>
+          <a:lstStyle/>
+          <a:p>
+            <a:pPr indent="0" marL="0">
+              <a:buNone/>
+            </a:pPr>
+            <a:r>
+              <a:rPr lang="en-US" sz="1200" dirty="0">
+                <a:solidFill>
+                  <a:srgbClr val="C8FF00"/>
+                </a:solidFill>
+                <a:latin typeface="Arial" pitchFamily="34" charset="0"/>
+                <a:ea typeface="Arial" pitchFamily="34" charset="-122"/>
+                <a:cs typeface="Arial" pitchFamily="34" charset="-120"/>
+              </a:rPr>
+              <a:t>⚡ </a:t>
+            </a:r>
+            <a:pPr indent="0" marL="0">
+              <a:buNone/>
+            </a:pPr>
+            <a:r>
+              <a:rPr lang="en-US" sz="1150" b="1" dirty="0">
+                <a:solidFill>
+                  <a:srgbClr val="F2F2F0"/>
+                </a:solidFill>
+                <a:latin typeface="Arial" pitchFamily="34" charset="0"/>
+                <a:ea typeface="Arial" pitchFamily="34" charset="-122"/>
+                <a:cs typeface="Arial" pitchFamily="34" charset="-120"/>
+              </a:rPr>
+              <a:t>The athlete count is the pricing engine. </a:t>
+            </a:r>
+            <a:pPr indent="0" marL="0">
+              <a:buNone/>
+            </a:pPr>
+            <a:r>
+              <a:rPr lang="en-US" sz="1150" dirty="0">
+                <a:solidFill>
+                  <a:srgbClr val="9CA0A8"/>
+                </a:solidFill>
+                <a:latin typeface="Arial" pitchFamily="34" charset="0"/>
+                <a:ea typeface="Arial" pitchFamily="34" charset="-122"/>
+                <a:cs typeface="Arial" pitchFamily="34" charset="-120"/>
+              </a:rPr>
+              <a:t>Department size × flat rate — bigger departments compound the contract.</a:t>
+            </a:r>
+            <a:endParaRPr lang="en-US" sz="1150" dirty="0"/>
+          </a:p>
+        </p:txBody>
+      </p:sp>
+    </p:spTree>
+  </p:cSld>
+  <p:clrMapOvr>
+    <a:masterClrMapping/>
+  </p:clrMapOvr>
 </p:sld>
 </file>
 

</xml_diff>